<commit_message>
fix(pitch-decks): remove rounding from PPTX screenshot images - rectangular screenshots instead of oval crop
</commit_message>
<xml_diff>
--- a/docs/pitch-decks/design-partner/pptx/01-healthcare.pptx
+++ b/docs/pitch-decks/design-partner/pptx/01-healthcare.pptx
@@ -4462,7 +4462,7 @@
             <a:off x="5303520" y="1097280"/>
             <a:ext cx="6400800" cy="4846320"/>
           </a:xfrm>
-          <a:prstGeom prst="ellipse">
+          <a:prstGeom prst="rect">
             <a:avLst/>
           </a:prstGeom>
         </p:spPr>
@@ -4810,7 +4810,7 @@
             <a:off x="5303520" y="1097280"/>
             <a:ext cx="6400800" cy="4846320"/>
           </a:xfrm>
-          <a:prstGeom prst="ellipse">
+          <a:prstGeom prst="rect">
             <a:avLst/>
           </a:prstGeom>
         </p:spPr>

</xml_diff>

<commit_message>
fix(pitch-decks): embed screenshots as base64 data in PPTX files - fixes broken image references showing alt text instead of actual screenshots
</commit_message>
<xml_diff>
--- a/docs/pitch-decks/design-partner/pptx/01-healthcare.pptx
+++ b/docs/pitch-decks/design-partner/pptx/01-healthcare.pptx
@@ -4445,7 +4445,7 @@
       </p:sp>
       <p:pic>
         <p:nvPicPr>
-          <p:cNvPr id="7" name="Image 0" descr="C:\Users\User\datacendia-core\docs\pitch-decks\screenshots\02-council-deliberation.png">    </p:cNvPr>
+          <p:cNvPr id="7" name="Image 0" descr="preencoded.png">    </p:cNvPr>
           <p:cNvPicPr>
             <a:picLocks noChangeAspect="1"/>
           </p:cNvPicPr>
@@ -4793,7 +4793,7 @@
       </p:sp>
       <p:pic>
         <p:nvPicPr>
-          <p:cNvPr id="7" name="Image 0" descr="C:\Users\User\datacendia-core\docs\pitch-decks\screenshots\05-decisions.png">    </p:cNvPr>
+          <p:cNvPr id="7" name="Image 0" descr="preencoded.png">    </p:cNvPr>
           <p:cNvPicPr>
             <a:picLocks noChangeAspect="1"/>
           </p:cNvPicPr>

</xml_diff>

<commit_message>
assets: embed 1,413 platform screenshots into all 240 pitch deck PPTX files
- Matched slide content keywords to appropriate screenshots
- Investor (10), Sales (25), Design Partner (25), Gamma (6), Investor-50 (51), Investor-100 (120), Main (3) decks updated
- Added embed_screenshots.py tooling script
</commit_message>
<xml_diff>
--- a/docs/pitch-decks/design-partner/pptx/01-healthcare.pptx
+++ b/docs/pitch-decks/design-partner/pptx/01-healthcare.pptx
@@ -1861,6 +1861,30 @@
           </a:p>
         </p:txBody>
       </p:sp>
+      <p:pic>
+        <p:nvPicPr>
+          <p:cNvPr id="9" name="Picture 8" descr="04-dcii-dashboard.png"/>
+          <p:cNvPicPr>
+            <a:picLocks noChangeAspect="1"/>
+          </p:cNvPicPr>
+          <p:nvPr/>
+        </p:nvPicPr>
+        <p:blipFill>
+          <a:blip r:embed="rId3"/>
+          <a:stretch>
+            <a:fillRect/>
+          </a:stretch>
+        </p:blipFill>
+        <p:spPr>
+          <a:xfrm>
+            <a:off x="6885432" y="1371600"/>
+            <a:ext cx="5029200" cy="3108960"/>
+          </a:xfrm>
+          <a:prstGeom prst="rect">
+            <a:avLst/>
+          </a:prstGeom>
+        </p:spPr>
+      </p:pic>
     </p:spTree>
   </p:cSld>
   <p:clrMapOvr>
@@ -2505,6 +2529,30 @@
           </a:p>
         </p:txBody>
       </p:sp>
+      <p:pic>
+        <p:nvPicPr>
+          <p:cNvPr id="9" name="Picture 8" descr="image.png"/>
+          <p:cNvPicPr>
+            <a:picLocks noChangeAspect="1"/>
+          </p:cNvPicPr>
+          <p:nvPr/>
+        </p:nvPicPr>
+        <p:blipFill>
+          <a:blip r:embed="rId3"/>
+          <a:stretch>
+            <a:fillRect/>
+          </a:stretch>
+        </p:blipFill>
+        <p:spPr>
+          <a:xfrm>
+            <a:off x="6885432" y="1371600"/>
+            <a:ext cx="5029200" cy="3108960"/>
+          </a:xfrm>
+          <a:prstGeom prst="rect">
+            <a:avLst/>
+          </a:prstGeom>
+        </p:spPr>
+      </p:pic>
     </p:spTree>
   </p:cSld>
   <p:clrMapOvr>
@@ -3189,6 +3237,30 @@
           </a:p>
         </p:txBody>
       </p:sp>
+      <p:pic>
+        <p:nvPicPr>
+          <p:cNvPr id="9" name="Picture 8" descr="image.png"/>
+          <p:cNvPicPr>
+            <a:picLocks noChangeAspect="1"/>
+          </p:cNvPicPr>
+          <p:nvPr/>
+        </p:nvPicPr>
+        <p:blipFill>
+          <a:blip r:embed="rId3"/>
+          <a:stretch>
+            <a:fillRect/>
+          </a:stretch>
+        </p:blipFill>
+        <p:spPr>
+          <a:xfrm>
+            <a:off x="6885432" y="1371600"/>
+            <a:ext cx="5029200" cy="3108960"/>
+          </a:xfrm>
+          <a:prstGeom prst="rect">
+            <a:avLst/>
+          </a:prstGeom>
+        </p:spPr>
+      </p:pic>
     </p:spTree>
   </p:cSld>
   <p:clrMapOvr>
@@ -3764,6 +3836,10 @@
           </a:solidFill>
           <a:ln/>
         </p:spPr>
+        <p:txBody>
+          <a:bodyPr/>
+          <a:p/>
+        </p:txBody>
       </p:sp>
       <p:sp>
         <p:nvSpPr>
@@ -3858,6 +3934,10 @@
           </a:solidFill>
           <a:ln/>
         </p:spPr>
+        <p:txBody>
+          <a:bodyPr/>
+          <a:p/>
+        </p:txBody>
       </p:sp>
       <p:sp>
         <p:nvSpPr>
@@ -3952,6 +4032,10 @@
           </a:solidFill>
           <a:ln/>
         </p:spPr>
+        <p:txBody>
+          <a:bodyPr/>
+          <a:p/>
+        </p:txBody>
       </p:sp>
       <p:sp>
         <p:nvSpPr>
@@ -4046,6 +4130,10 @@
           </a:solidFill>
           <a:ln/>
         </p:spPr>
+        <p:txBody>
+          <a:bodyPr/>
+          <a:p/>
+        </p:txBody>
       </p:sp>
       <p:sp>
         <p:nvSpPr>
@@ -4443,9 +4531,81 @@
           </a:p>
         </p:txBody>
       </p:sp>
+      <p:sp>
+        <p:nvSpPr>
+          <p:cNvPr id="8" name="Text 5"/>
+          <p:cNvSpPr/>
+          <p:nvPr/>
+        </p:nvSpPr>
+        <p:spPr>
+          <a:xfrm>
+            <a:off x="457200" y="6400800"/>
+            <a:ext cx="3657600" cy="274320"/>
+          </a:xfrm>
+          <a:prstGeom prst="rect">
+            <a:avLst/>
+          </a:prstGeom>
+          <a:noFill/>
+          <a:ln/>
+        </p:spPr>
+        <p:txBody>
+          <a:bodyPr wrap="square" rtlCol="0" anchor="ctr"/>
+          <a:lstStyle/>
+          <a:p>
+            <a:pPr indent="0" marL="0">
+              <a:buNone/>
+            </a:pPr>
+            <a:r>
+              <a:rPr lang="en-US" sz="800" dirty="0">
+                <a:solidFill>
+                  <a:srgbClr val="8B8FA3"/>
+                </a:solidFill>
+              </a:rPr>
+              <a:t>© 2024-2026 Datacendia, LLC</a:t>
+            </a:r>
+            <a:endParaRPr lang="en-US" sz="800" dirty="0"/>
+          </a:p>
+        </p:txBody>
+      </p:sp>
+      <p:sp>
+        <p:nvSpPr>
+          <p:cNvPr id="9" name="Text 6"/>
+          <p:cNvSpPr/>
+          <p:nvPr/>
+        </p:nvSpPr>
+        <p:spPr>
+          <a:xfrm>
+            <a:off x="8229600" y="6400800"/>
+            <a:ext cx="3657600" cy="274320"/>
+          </a:xfrm>
+          <a:prstGeom prst="rect">
+            <a:avLst/>
+          </a:prstGeom>
+          <a:noFill/>
+          <a:ln/>
+        </p:spPr>
+        <p:txBody>
+          <a:bodyPr wrap="square" rtlCol="0" anchor="ctr"/>
+          <a:lstStyle/>
+          <a:p>
+            <a:pPr algn="r" indent="0" marL="0">
+              <a:buNone/>
+            </a:pPr>
+            <a:r>
+              <a:rPr lang="en-US" sz="800" dirty="0">
+                <a:solidFill>
+                  <a:srgbClr val="8B8FA3"/>
+                </a:solidFill>
+              </a:rPr>
+              <a:t>datacendia.com</a:t>
+            </a:r>
+            <a:endParaRPr lang="en-US" sz="800" dirty="0"/>
+          </a:p>
+        </p:txBody>
+      </p:sp>
       <p:pic>
         <p:nvPicPr>
-          <p:cNvPr id="7" name="Image 0" descr="preencoded.png">    </p:cNvPr>
+          <p:cNvPr id="10" name="Picture 9" descr="image.png"/>
           <p:cNvPicPr>
             <a:picLocks noChangeAspect="1"/>
           </p:cNvPicPr>
@@ -4459,86 +4619,14 @@
         </p:blipFill>
         <p:spPr>
           <a:xfrm>
-            <a:off x="5303520" y="1097280"/>
-            <a:ext cx="6400800" cy="4846320"/>
+            <a:off x="6885432" y="1371600"/>
+            <a:ext cx="5029200" cy="3108960"/>
           </a:xfrm>
           <a:prstGeom prst="rect">
             <a:avLst/>
           </a:prstGeom>
         </p:spPr>
       </p:pic>
-      <p:sp>
-        <p:nvSpPr>
-          <p:cNvPr id="8" name="Text 5"/>
-          <p:cNvSpPr/>
-          <p:nvPr/>
-        </p:nvSpPr>
-        <p:spPr>
-          <a:xfrm>
-            <a:off x="457200" y="6400800"/>
-            <a:ext cx="3657600" cy="274320"/>
-          </a:xfrm>
-          <a:prstGeom prst="rect">
-            <a:avLst/>
-          </a:prstGeom>
-          <a:noFill/>
-          <a:ln/>
-        </p:spPr>
-        <p:txBody>
-          <a:bodyPr wrap="square" rtlCol="0" anchor="ctr"/>
-          <a:lstStyle/>
-          <a:p>
-            <a:pPr indent="0" marL="0">
-              <a:buNone/>
-            </a:pPr>
-            <a:r>
-              <a:rPr lang="en-US" sz="800" dirty="0">
-                <a:solidFill>
-                  <a:srgbClr val="8B8FA3"/>
-                </a:solidFill>
-              </a:rPr>
-              <a:t>© 2024-2026 Datacendia, LLC</a:t>
-            </a:r>
-            <a:endParaRPr lang="en-US" sz="800" dirty="0"/>
-          </a:p>
-        </p:txBody>
-      </p:sp>
-      <p:sp>
-        <p:nvSpPr>
-          <p:cNvPr id="9" name="Text 6"/>
-          <p:cNvSpPr/>
-          <p:nvPr/>
-        </p:nvSpPr>
-        <p:spPr>
-          <a:xfrm>
-            <a:off x="8229600" y="6400800"/>
-            <a:ext cx="3657600" cy="274320"/>
-          </a:xfrm>
-          <a:prstGeom prst="rect">
-            <a:avLst/>
-          </a:prstGeom>
-          <a:noFill/>
-          <a:ln/>
-        </p:spPr>
-        <p:txBody>
-          <a:bodyPr wrap="square" rtlCol="0" anchor="ctr"/>
-          <a:lstStyle/>
-          <a:p>
-            <a:pPr algn="r" indent="0" marL="0">
-              <a:buNone/>
-            </a:pPr>
-            <a:r>
-              <a:rPr lang="en-US" sz="800" dirty="0">
-                <a:solidFill>
-                  <a:srgbClr val="8B8FA3"/>
-                </a:solidFill>
-              </a:rPr>
-              <a:t>datacendia.com</a:t>
-            </a:r>
-            <a:endParaRPr lang="en-US" sz="800" dirty="0"/>
-          </a:p>
-        </p:txBody>
-      </p:sp>
     </p:spTree>
   </p:cSld>
   <p:clrMapOvr>
@@ -4791,9 +4879,81 @@
           </a:p>
         </p:txBody>
       </p:sp>
+      <p:sp>
+        <p:nvSpPr>
+          <p:cNvPr id="8" name="Text 5"/>
+          <p:cNvSpPr/>
+          <p:nvPr/>
+        </p:nvSpPr>
+        <p:spPr>
+          <a:xfrm>
+            <a:off x="457200" y="6400800"/>
+            <a:ext cx="3657600" cy="274320"/>
+          </a:xfrm>
+          <a:prstGeom prst="rect">
+            <a:avLst/>
+          </a:prstGeom>
+          <a:noFill/>
+          <a:ln/>
+        </p:spPr>
+        <p:txBody>
+          <a:bodyPr wrap="square" rtlCol="0" anchor="ctr"/>
+          <a:lstStyle/>
+          <a:p>
+            <a:pPr indent="0" marL="0">
+              <a:buNone/>
+            </a:pPr>
+            <a:r>
+              <a:rPr lang="en-US" sz="800" dirty="0">
+                <a:solidFill>
+                  <a:srgbClr val="8B8FA3"/>
+                </a:solidFill>
+              </a:rPr>
+              <a:t>© 2024-2026 Datacendia, LLC</a:t>
+            </a:r>
+            <a:endParaRPr lang="en-US" sz="800" dirty="0"/>
+          </a:p>
+        </p:txBody>
+      </p:sp>
+      <p:sp>
+        <p:nvSpPr>
+          <p:cNvPr id="9" name="Text 6"/>
+          <p:cNvSpPr/>
+          <p:nvPr/>
+        </p:nvSpPr>
+        <p:spPr>
+          <a:xfrm>
+            <a:off x="8229600" y="6400800"/>
+            <a:ext cx="3657600" cy="274320"/>
+          </a:xfrm>
+          <a:prstGeom prst="rect">
+            <a:avLst/>
+          </a:prstGeom>
+          <a:noFill/>
+          <a:ln/>
+        </p:spPr>
+        <p:txBody>
+          <a:bodyPr wrap="square" rtlCol="0" anchor="ctr"/>
+          <a:lstStyle/>
+          <a:p>
+            <a:pPr algn="r" indent="0" marL="0">
+              <a:buNone/>
+            </a:pPr>
+            <a:r>
+              <a:rPr lang="en-US" sz="800" dirty="0">
+                <a:solidFill>
+                  <a:srgbClr val="8B8FA3"/>
+                </a:solidFill>
+              </a:rPr>
+              <a:t>datacendia.com</a:t>
+            </a:r>
+            <a:endParaRPr lang="en-US" sz="800" dirty="0"/>
+          </a:p>
+        </p:txBody>
+      </p:sp>
       <p:pic>
         <p:nvPicPr>
-          <p:cNvPr id="7" name="Image 0" descr="preencoded.png">    </p:cNvPr>
+          <p:cNvPr id="10" name="Picture 9" descr="image.png"/>
           <p:cNvPicPr>
             <a:picLocks noChangeAspect="1"/>
           </p:cNvPicPr>
@@ -4807,86 +4967,14 @@
         </p:blipFill>
         <p:spPr>
           <a:xfrm>
-            <a:off x="5303520" y="1097280"/>
-            <a:ext cx="6400800" cy="4846320"/>
+            <a:off x="6885432" y="1371600"/>
+            <a:ext cx="5029200" cy="3108960"/>
           </a:xfrm>
           <a:prstGeom prst="rect">
             <a:avLst/>
           </a:prstGeom>
         </p:spPr>
       </p:pic>
-      <p:sp>
-        <p:nvSpPr>
-          <p:cNvPr id="8" name="Text 5"/>
-          <p:cNvSpPr/>
-          <p:nvPr/>
-        </p:nvSpPr>
-        <p:spPr>
-          <a:xfrm>
-            <a:off x="457200" y="6400800"/>
-            <a:ext cx="3657600" cy="274320"/>
-          </a:xfrm>
-          <a:prstGeom prst="rect">
-            <a:avLst/>
-          </a:prstGeom>
-          <a:noFill/>
-          <a:ln/>
-        </p:spPr>
-        <p:txBody>
-          <a:bodyPr wrap="square" rtlCol="0" anchor="ctr"/>
-          <a:lstStyle/>
-          <a:p>
-            <a:pPr indent="0" marL="0">
-              <a:buNone/>
-            </a:pPr>
-            <a:r>
-              <a:rPr lang="en-US" sz="800" dirty="0">
-                <a:solidFill>
-                  <a:srgbClr val="8B8FA3"/>
-                </a:solidFill>
-              </a:rPr>
-              <a:t>© 2024-2026 Datacendia, LLC</a:t>
-            </a:r>
-            <a:endParaRPr lang="en-US" sz="800" dirty="0"/>
-          </a:p>
-        </p:txBody>
-      </p:sp>
-      <p:sp>
-        <p:nvSpPr>
-          <p:cNvPr id="9" name="Text 6"/>
-          <p:cNvSpPr/>
-          <p:nvPr/>
-        </p:nvSpPr>
-        <p:spPr>
-          <a:xfrm>
-            <a:off x="8229600" y="6400800"/>
-            <a:ext cx="3657600" cy="274320"/>
-          </a:xfrm>
-          <a:prstGeom prst="rect">
-            <a:avLst/>
-          </a:prstGeom>
-          <a:noFill/>
-          <a:ln/>
-        </p:spPr>
-        <p:txBody>
-          <a:bodyPr wrap="square" rtlCol="0" anchor="ctr"/>
-          <a:lstStyle/>
-          <a:p>
-            <a:pPr algn="r" indent="0" marL="0">
-              <a:buNone/>
-            </a:pPr>
-            <a:r>
-              <a:rPr lang="en-US" sz="800" dirty="0">
-                <a:solidFill>
-                  <a:srgbClr val="8B8FA3"/>
-                </a:solidFill>
-              </a:rPr>
-              <a:t>datacendia.com</a:t>
-            </a:r>
-            <a:endParaRPr lang="en-US" sz="800" dirty="0"/>
-          </a:p>
-        </p:txBody>
-      </p:sp>
     </p:spTree>
   </p:cSld>
   <p:clrMapOvr>

</xml_diff>

<commit_message>
Revert "assets: embed 1,413 platform screenshots into all 240 pitch deck PPTX files"
This reverts commit 3282c349b52e40fd9528717f801d27b1c34d8bbf.
</commit_message>
<xml_diff>
--- a/docs/pitch-decks/design-partner/pptx/01-healthcare.pptx
+++ b/docs/pitch-decks/design-partner/pptx/01-healthcare.pptx
@@ -1861,30 +1861,6 @@
           </a:p>
         </p:txBody>
       </p:sp>
-      <p:pic>
-        <p:nvPicPr>
-          <p:cNvPr id="9" name="Picture 8" descr="04-dcii-dashboard.png"/>
-          <p:cNvPicPr>
-            <a:picLocks noChangeAspect="1"/>
-          </p:cNvPicPr>
-          <p:nvPr/>
-        </p:nvPicPr>
-        <p:blipFill>
-          <a:blip r:embed="rId3"/>
-          <a:stretch>
-            <a:fillRect/>
-          </a:stretch>
-        </p:blipFill>
-        <p:spPr>
-          <a:xfrm>
-            <a:off x="6885432" y="1371600"/>
-            <a:ext cx="5029200" cy="3108960"/>
-          </a:xfrm>
-          <a:prstGeom prst="rect">
-            <a:avLst/>
-          </a:prstGeom>
-        </p:spPr>
-      </p:pic>
     </p:spTree>
   </p:cSld>
   <p:clrMapOvr>
@@ -2529,30 +2505,6 @@
           </a:p>
         </p:txBody>
       </p:sp>
-      <p:pic>
-        <p:nvPicPr>
-          <p:cNvPr id="9" name="Picture 8" descr="image.png"/>
-          <p:cNvPicPr>
-            <a:picLocks noChangeAspect="1"/>
-          </p:cNvPicPr>
-          <p:nvPr/>
-        </p:nvPicPr>
-        <p:blipFill>
-          <a:blip r:embed="rId3"/>
-          <a:stretch>
-            <a:fillRect/>
-          </a:stretch>
-        </p:blipFill>
-        <p:spPr>
-          <a:xfrm>
-            <a:off x="6885432" y="1371600"/>
-            <a:ext cx="5029200" cy="3108960"/>
-          </a:xfrm>
-          <a:prstGeom prst="rect">
-            <a:avLst/>
-          </a:prstGeom>
-        </p:spPr>
-      </p:pic>
     </p:spTree>
   </p:cSld>
   <p:clrMapOvr>
@@ -3237,30 +3189,6 @@
           </a:p>
         </p:txBody>
       </p:sp>
-      <p:pic>
-        <p:nvPicPr>
-          <p:cNvPr id="9" name="Picture 8" descr="image.png"/>
-          <p:cNvPicPr>
-            <a:picLocks noChangeAspect="1"/>
-          </p:cNvPicPr>
-          <p:nvPr/>
-        </p:nvPicPr>
-        <p:blipFill>
-          <a:blip r:embed="rId3"/>
-          <a:stretch>
-            <a:fillRect/>
-          </a:stretch>
-        </p:blipFill>
-        <p:spPr>
-          <a:xfrm>
-            <a:off x="6885432" y="1371600"/>
-            <a:ext cx="5029200" cy="3108960"/>
-          </a:xfrm>
-          <a:prstGeom prst="rect">
-            <a:avLst/>
-          </a:prstGeom>
-        </p:spPr>
-      </p:pic>
     </p:spTree>
   </p:cSld>
   <p:clrMapOvr>
@@ -3836,10 +3764,6 @@
           </a:solidFill>
           <a:ln/>
         </p:spPr>
-        <p:txBody>
-          <a:bodyPr/>
-          <a:p/>
-        </p:txBody>
       </p:sp>
       <p:sp>
         <p:nvSpPr>
@@ -3934,10 +3858,6 @@
           </a:solidFill>
           <a:ln/>
         </p:spPr>
-        <p:txBody>
-          <a:bodyPr/>
-          <a:p/>
-        </p:txBody>
       </p:sp>
       <p:sp>
         <p:nvSpPr>
@@ -4032,10 +3952,6 @@
           </a:solidFill>
           <a:ln/>
         </p:spPr>
-        <p:txBody>
-          <a:bodyPr/>
-          <a:p/>
-        </p:txBody>
       </p:sp>
       <p:sp>
         <p:nvSpPr>
@@ -4130,10 +4046,6 @@
           </a:solidFill>
           <a:ln/>
         </p:spPr>
-        <p:txBody>
-          <a:bodyPr/>
-          <a:p/>
-        </p:txBody>
       </p:sp>
       <p:sp>
         <p:nvSpPr>
@@ -4531,81 +4443,9 @@
           </a:p>
         </p:txBody>
       </p:sp>
-      <p:sp>
-        <p:nvSpPr>
-          <p:cNvPr id="8" name="Text 5"/>
-          <p:cNvSpPr/>
-          <p:nvPr/>
-        </p:nvSpPr>
-        <p:spPr>
-          <a:xfrm>
-            <a:off x="457200" y="6400800"/>
-            <a:ext cx="3657600" cy="274320"/>
-          </a:xfrm>
-          <a:prstGeom prst="rect">
-            <a:avLst/>
-          </a:prstGeom>
-          <a:noFill/>
-          <a:ln/>
-        </p:spPr>
-        <p:txBody>
-          <a:bodyPr wrap="square" rtlCol="0" anchor="ctr"/>
-          <a:lstStyle/>
-          <a:p>
-            <a:pPr indent="0" marL="0">
-              <a:buNone/>
-            </a:pPr>
-            <a:r>
-              <a:rPr lang="en-US" sz="800" dirty="0">
-                <a:solidFill>
-                  <a:srgbClr val="8B8FA3"/>
-                </a:solidFill>
-              </a:rPr>
-              <a:t>© 2024-2026 Datacendia, LLC</a:t>
-            </a:r>
-            <a:endParaRPr lang="en-US" sz="800" dirty="0"/>
-          </a:p>
-        </p:txBody>
-      </p:sp>
-      <p:sp>
-        <p:nvSpPr>
-          <p:cNvPr id="9" name="Text 6"/>
-          <p:cNvSpPr/>
-          <p:nvPr/>
-        </p:nvSpPr>
-        <p:spPr>
-          <a:xfrm>
-            <a:off x="8229600" y="6400800"/>
-            <a:ext cx="3657600" cy="274320"/>
-          </a:xfrm>
-          <a:prstGeom prst="rect">
-            <a:avLst/>
-          </a:prstGeom>
-          <a:noFill/>
-          <a:ln/>
-        </p:spPr>
-        <p:txBody>
-          <a:bodyPr wrap="square" rtlCol="0" anchor="ctr"/>
-          <a:lstStyle/>
-          <a:p>
-            <a:pPr algn="r" indent="0" marL="0">
-              <a:buNone/>
-            </a:pPr>
-            <a:r>
-              <a:rPr lang="en-US" sz="800" dirty="0">
-                <a:solidFill>
-                  <a:srgbClr val="8B8FA3"/>
-                </a:solidFill>
-              </a:rPr>
-              <a:t>datacendia.com</a:t>
-            </a:r>
-            <a:endParaRPr lang="en-US" sz="800" dirty="0"/>
-          </a:p>
-        </p:txBody>
-      </p:sp>
       <p:pic>
         <p:nvPicPr>
-          <p:cNvPr id="10" name="Picture 9" descr="image.png"/>
+          <p:cNvPr id="7" name="Image 0" descr="preencoded.png">    </p:cNvPr>
           <p:cNvPicPr>
             <a:picLocks noChangeAspect="1"/>
           </p:cNvPicPr>
@@ -4619,14 +4459,86 @@
         </p:blipFill>
         <p:spPr>
           <a:xfrm>
-            <a:off x="6885432" y="1371600"/>
-            <a:ext cx="5029200" cy="3108960"/>
+            <a:off x="5303520" y="1097280"/>
+            <a:ext cx="6400800" cy="4846320"/>
           </a:xfrm>
           <a:prstGeom prst="rect">
             <a:avLst/>
           </a:prstGeom>
         </p:spPr>
       </p:pic>
+      <p:sp>
+        <p:nvSpPr>
+          <p:cNvPr id="8" name="Text 5"/>
+          <p:cNvSpPr/>
+          <p:nvPr/>
+        </p:nvSpPr>
+        <p:spPr>
+          <a:xfrm>
+            <a:off x="457200" y="6400800"/>
+            <a:ext cx="3657600" cy="274320"/>
+          </a:xfrm>
+          <a:prstGeom prst="rect">
+            <a:avLst/>
+          </a:prstGeom>
+          <a:noFill/>
+          <a:ln/>
+        </p:spPr>
+        <p:txBody>
+          <a:bodyPr wrap="square" rtlCol="0" anchor="ctr"/>
+          <a:lstStyle/>
+          <a:p>
+            <a:pPr indent="0" marL="0">
+              <a:buNone/>
+            </a:pPr>
+            <a:r>
+              <a:rPr lang="en-US" sz="800" dirty="0">
+                <a:solidFill>
+                  <a:srgbClr val="8B8FA3"/>
+                </a:solidFill>
+              </a:rPr>
+              <a:t>© 2024-2026 Datacendia, LLC</a:t>
+            </a:r>
+            <a:endParaRPr lang="en-US" sz="800" dirty="0"/>
+          </a:p>
+        </p:txBody>
+      </p:sp>
+      <p:sp>
+        <p:nvSpPr>
+          <p:cNvPr id="9" name="Text 6"/>
+          <p:cNvSpPr/>
+          <p:nvPr/>
+        </p:nvSpPr>
+        <p:spPr>
+          <a:xfrm>
+            <a:off x="8229600" y="6400800"/>
+            <a:ext cx="3657600" cy="274320"/>
+          </a:xfrm>
+          <a:prstGeom prst="rect">
+            <a:avLst/>
+          </a:prstGeom>
+          <a:noFill/>
+          <a:ln/>
+        </p:spPr>
+        <p:txBody>
+          <a:bodyPr wrap="square" rtlCol="0" anchor="ctr"/>
+          <a:lstStyle/>
+          <a:p>
+            <a:pPr algn="r" indent="0" marL="0">
+              <a:buNone/>
+            </a:pPr>
+            <a:r>
+              <a:rPr lang="en-US" sz="800" dirty="0">
+                <a:solidFill>
+                  <a:srgbClr val="8B8FA3"/>
+                </a:solidFill>
+              </a:rPr>
+              <a:t>datacendia.com</a:t>
+            </a:r>
+            <a:endParaRPr lang="en-US" sz="800" dirty="0"/>
+          </a:p>
+        </p:txBody>
+      </p:sp>
     </p:spTree>
   </p:cSld>
   <p:clrMapOvr>
@@ -4879,81 +4791,9 @@
           </a:p>
         </p:txBody>
       </p:sp>
-      <p:sp>
-        <p:nvSpPr>
-          <p:cNvPr id="8" name="Text 5"/>
-          <p:cNvSpPr/>
-          <p:nvPr/>
-        </p:nvSpPr>
-        <p:spPr>
-          <a:xfrm>
-            <a:off x="457200" y="6400800"/>
-            <a:ext cx="3657600" cy="274320"/>
-          </a:xfrm>
-          <a:prstGeom prst="rect">
-            <a:avLst/>
-          </a:prstGeom>
-          <a:noFill/>
-          <a:ln/>
-        </p:spPr>
-        <p:txBody>
-          <a:bodyPr wrap="square" rtlCol="0" anchor="ctr"/>
-          <a:lstStyle/>
-          <a:p>
-            <a:pPr indent="0" marL="0">
-              <a:buNone/>
-            </a:pPr>
-            <a:r>
-              <a:rPr lang="en-US" sz="800" dirty="0">
-                <a:solidFill>
-                  <a:srgbClr val="8B8FA3"/>
-                </a:solidFill>
-              </a:rPr>
-              <a:t>© 2024-2026 Datacendia, LLC</a:t>
-            </a:r>
-            <a:endParaRPr lang="en-US" sz="800" dirty="0"/>
-          </a:p>
-        </p:txBody>
-      </p:sp>
-      <p:sp>
-        <p:nvSpPr>
-          <p:cNvPr id="9" name="Text 6"/>
-          <p:cNvSpPr/>
-          <p:nvPr/>
-        </p:nvSpPr>
-        <p:spPr>
-          <a:xfrm>
-            <a:off x="8229600" y="6400800"/>
-            <a:ext cx="3657600" cy="274320"/>
-          </a:xfrm>
-          <a:prstGeom prst="rect">
-            <a:avLst/>
-          </a:prstGeom>
-          <a:noFill/>
-          <a:ln/>
-        </p:spPr>
-        <p:txBody>
-          <a:bodyPr wrap="square" rtlCol="0" anchor="ctr"/>
-          <a:lstStyle/>
-          <a:p>
-            <a:pPr algn="r" indent="0" marL="0">
-              <a:buNone/>
-            </a:pPr>
-            <a:r>
-              <a:rPr lang="en-US" sz="800" dirty="0">
-                <a:solidFill>
-                  <a:srgbClr val="8B8FA3"/>
-                </a:solidFill>
-              </a:rPr>
-              <a:t>datacendia.com</a:t>
-            </a:r>
-            <a:endParaRPr lang="en-US" sz="800" dirty="0"/>
-          </a:p>
-        </p:txBody>
-      </p:sp>
       <p:pic>
         <p:nvPicPr>
-          <p:cNvPr id="10" name="Picture 9" descr="image.png"/>
+          <p:cNvPr id="7" name="Image 0" descr="preencoded.png">    </p:cNvPr>
           <p:cNvPicPr>
             <a:picLocks noChangeAspect="1"/>
           </p:cNvPicPr>
@@ -4967,14 +4807,86 @@
         </p:blipFill>
         <p:spPr>
           <a:xfrm>
-            <a:off x="6885432" y="1371600"/>
-            <a:ext cx="5029200" cy="3108960"/>
+            <a:off x="5303520" y="1097280"/>
+            <a:ext cx="6400800" cy="4846320"/>
           </a:xfrm>
           <a:prstGeom prst="rect">
             <a:avLst/>
           </a:prstGeom>
         </p:spPr>
       </p:pic>
+      <p:sp>
+        <p:nvSpPr>
+          <p:cNvPr id="8" name="Text 5"/>
+          <p:cNvSpPr/>
+          <p:nvPr/>
+        </p:nvSpPr>
+        <p:spPr>
+          <a:xfrm>
+            <a:off x="457200" y="6400800"/>
+            <a:ext cx="3657600" cy="274320"/>
+          </a:xfrm>
+          <a:prstGeom prst="rect">
+            <a:avLst/>
+          </a:prstGeom>
+          <a:noFill/>
+          <a:ln/>
+        </p:spPr>
+        <p:txBody>
+          <a:bodyPr wrap="square" rtlCol="0" anchor="ctr"/>
+          <a:lstStyle/>
+          <a:p>
+            <a:pPr indent="0" marL="0">
+              <a:buNone/>
+            </a:pPr>
+            <a:r>
+              <a:rPr lang="en-US" sz="800" dirty="0">
+                <a:solidFill>
+                  <a:srgbClr val="8B8FA3"/>
+                </a:solidFill>
+              </a:rPr>
+              <a:t>© 2024-2026 Datacendia, LLC</a:t>
+            </a:r>
+            <a:endParaRPr lang="en-US" sz="800" dirty="0"/>
+          </a:p>
+        </p:txBody>
+      </p:sp>
+      <p:sp>
+        <p:nvSpPr>
+          <p:cNvPr id="9" name="Text 6"/>
+          <p:cNvSpPr/>
+          <p:nvPr/>
+        </p:nvSpPr>
+        <p:spPr>
+          <a:xfrm>
+            <a:off x="8229600" y="6400800"/>
+            <a:ext cx="3657600" cy="274320"/>
+          </a:xfrm>
+          <a:prstGeom prst="rect">
+            <a:avLst/>
+          </a:prstGeom>
+          <a:noFill/>
+          <a:ln/>
+        </p:spPr>
+        <p:txBody>
+          <a:bodyPr wrap="square" rtlCol="0" anchor="ctr"/>
+          <a:lstStyle/>
+          <a:p>
+            <a:pPr algn="r" indent="0" marL="0">
+              <a:buNone/>
+            </a:pPr>
+            <a:r>
+              <a:rPr lang="en-US" sz="800" dirty="0">
+                <a:solidFill>
+                  <a:srgbClr val="8B8FA3"/>
+                </a:solidFill>
+              </a:rPr>
+              <a:t>datacendia.com</a:t>
+            </a:r>
+            <a:endParaRPr lang="en-US" sz="800" dirty="0"/>
+          </a:p>
+        </p:txBody>
+      </p:sp>
     </p:spTree>
   </p:cSld>
   <p:clrMapOvr>

</xml_diff>

<commit_message>
assets: embed platform screenshots into all 240 pitch decks (proper placement)
- Replaced 478 image placeholders (2 per deck) with correct screenshots
- MULTI-AGENT DECISION ENGINE slides -> 02-council-deliberation.png
- DECISION AUDIT TRAIL slides -> 05-decisions.png
- Exact same position (5.8,1.2) and size (7.0x5.3in) as original placeholders
- Added audit and embed tooling scripts
</commit_message>
<xml_diff>
--- a/docs/pitch-decks/design-partner/pptx/01-healthcare.pptx
+++ b/docs/pitch-decks/design-partner/pptx/01-healthcare.pptx
@@ -4443,9 +4443,81 @@
           </a:p>
         </p:txBody>
       </p:sp>
+      <p:sp>
+        <p:nvSpPr>
+          <p:cNvPr id="8" name="Text 5"/>
+          <p:cNvSpPr/>
+          <p:nvPr/>
+        </p:nvSpPr>
+        <p:spPr>
+          <a:xfrm>
+            <a:off x="457200" y="6400800"/>
+            <a:ext cx="3657600" cy="274320"/>
+          </a:xfrm>
+          <a:prstGeom prst="rect">
+            <a:avLst/>
+          </a:prstGeom>
+          <a:noFill/>
+          <a:ln/>
+        </p:spPr>
+        <p:txBody>
+          <a:bodyPr wrap="square" rtlCol="0" anchor="ctr"/>
+          <a:lstStyle/>
+          <a:p>
+            <a:pPr indent="0" marL="0">
+              <a:buNone/>
+            </a:pPr>
+            <a:r>
+              <a:rPr lang="en-US" sz="800" dirty="0">
+                <a:solidFill>
+                  <a:srgbClr val="8B8FA3"/>
+                </a:solidFill>
+              </a:rPr>
+              <a:t>© 2024-2026 Datacendia, LLC</a:t>
+            </a:r>
+            <a:endParaRPr lang="en-US" sz="800" dirty="0"/>
+          </a:p>
+        </p:txBody>
+      </p:sp>
+      <p:sp>
+        <p:nvSpPr>
+          <p:cNvPr id="9" name="Text 6"/>
+          <p:cNvSpPr/>
+          <p:nvPr/>
+        </p:nvSpPr>
+        <p:spPr>
+          <a:xfrm>
+            <a:off x="8229600" y="6400800"/>
+            <a:ext cx="3657600" cy="274320"/>
+          </a:xfrm>
+          <a:prstGeom prst="rect">
+            <a:avLst/>
+          </a:prstGeom>
+          <a:noFill/>
+          <a:ln/>
+        </p:spPr>
+        <p:txBody>
+          <a:bodyPr wrap="square" rtlCol="0" anchor="ctr"/>
+          <a:lstStyle/>
+          <a:p>
+            <a:pPr algn="r" indent="0" marL="0">
+              <a:buNone/>
+            </a:pPr>
+            <a:r>
+              <a:rPr lang="en-US" sz="800" dirty="0">
+                <a:solidFill>
+                  <a:srgbClr val="8B8FA3"/>
+                </a:solidFill>
+              </a:rPr>
+              <a:t>datacendia.com</a:t>
+            </a:r>
+            <a:endParaRPr lang="en-US" sz="800" dirty="0"/>
+          </a:p>
+        </p:txBody>
+      </p:sp>
       <p:pic>
         <p:nvPicPr>
-          <p:cNvPr id="7" name="Image 0" descr="preencoded.png">    </p:cNvPr>
+          <p:cNvPr id="10" name="Picture 9" descr="image.png"/>
           <p:cNvPicPr>
             <a:picLocks noChangeAspect="1"/>
           </p:cNvPicPr>
@@ -4467,78 +4539,6 @@
           </a:prstGeom>
         </p:spPr>
       </p:pic>
-      <p:sp>
-        <p:nvSpPr>
-          <p:cNvPr id="8" name="Text 5"/>
-          <p:cNvSpPr/>
-          <p:nvPr/>
-        </p:nvSpPr>
-        <p:spPr>
-          <a:xfrm>
-            <a:off x="457200" y="6400800"/>
-            <a:ext cx="3657600" cy="274320"/>
-          </a:xfrm>
-          <a:prstGeom prst="rect">
-            <a:avLst/>
-          </a:prstGeom>
-          <a:noFill/>
-          <a:ln/>
-        </p:spPr>
-        <p:txBody>
-          <a:bodyPr wrap="square" rtlCol="0" anchor="ctr"/>
-          <a:lstStyle/>
-          <a:p>
-            <a:pPr indent="0" marL="0">
-              <a:buNone/>
-            </a:pPr>
-            <a:r>
-              <a:rPr lang="en-US" sz="800" dirty="0">
-                <a:solidFill>
-                  <a:srgbClr val="8B8FA3"/>
-                </a:solidFill>
-              </a:rPr>
-              <a:t>© 2024-2026 Datacendia, LLC</a:t>
-            </a:r>
-            <a:endParaRPr lang="en-US" sz="800" dirty="0"/>
-          </a:p>
-        </p:txBody>
-      </p:sp>
-      <p:sp>
-        <p:nvSpPr>
-          <p:cNvPr id="9" name="Text 6"/>
-          <p:cNvSpPr/>
-          <p:nvPr/>
-        </p:nvSpPr>
-        <p:spPr>
-          <a:xfrm>
-            <a:off x="8229600" y="6400800"/>
-            <a:ext cx="3657600" cy="274320"/>
-          </a:xfrm>
-          <a:prstGeom prst="rect">
-            <a:avLst/>
-          </a:prstGeom>
-          <a:noFill/>
-          <a:ln/>
-        </p:spPr>
-        <p:txBody>
-          <a:bodyPr wrap="square" rtlCol="0" anchor="ctr"/>
-          <a:lstStyle/>
-          <a:p>
-            <a:pPr algn="r" indent="0" marL="0">
-              <a:buNone/>
-            </a:pPr>
-            <a:r>
-              <a:rPr lang="en-US" sz="800" dirty="0">
-                <a:solidFill>
-                  <a:srgbClr val="8B8FA3"/>
-                </a:solidFill>
-              </a:rPr>
-              <a:t>datacendia.com</a:t>
-            </a:r>
-            <a:endParaRPr lang="en-US" sz="800" dirty="0"/>
-          </a:p>
-        </p:txBody>
-      </p:sp>
     </p:spTree>
   </p:cSld>
   <p:clrMapOvr>
@@ -4791,9 +4791,81 @@
           </a:p>
         </p:txBody>
       </p:sp>
+      <p:sp>
+        <p:nvSpPr>
+          <p:cNvPr id="8" name="Text 5"/>
+          <p:cNvSpPr/>
+          <p:nvPr/>
+        </p:nvSpPr>
+        <p:spPr>
+          <a:xfrm>
+            <a:off x="457200" y="6400800"/>
+            <a:ext cx="3657600" cy="274320"/>
+          </a:xfrm>
+          <a:prstGeom prst="rect">
+            <a:avLst/>
+          </a:prstGeom>
+          <a:noFill/>
+          <a:ln/>
+        </p:spPr>
+        <p:txBody>
+          <a:bodyPr wrap="square" rtlCol="0" anchor="ctr"/>
+          <a:lstStyle/>
+          <a:p>
+            <a:pPr indent="0" marL="0">
+              <a:buNone/>
+            </a:pPr>
+            <a:r>
+              <a:rPr lang="en-US" sz="800" dirty="0">
+                <a:solidFill>
+                  <a:srgbClr val="8B8FA3"/>
+                </a:solidFill>
+              </a:rPr>
+              <a:t>© 2024-2026 Datacendia, LLC</a:t>
+            </a:r>
+            <a:endParaRPr lang="en-US" sz="800" dirty="0"/>
+          </a:p>
+        </p:txBody>
+      </p:sp>
+      <p:sp>
+        <p:nvSpPr>
+          <p:cNvPr id="9" name="Text 6"/>
+          <p:cNvSpPr/>
+          <p:nvPr/>
+        </p:nvSpPr>
+        <p:spPr>
+          <a:xfrm>
+            <a:off x="8229600" y="6400800"/>
+            <a:ext cx="3657600" cy="274320"/>
+          </a:xfrm>
+          <a:prstGeom prst="rect">
+            <a:avLst/>
+          </a:prstGeom>
+          <a:noFill/>
+          <a:ln/>
+        </p:spPr>
+        <p:txBody>
+          <a:bodyPr wrap="square" rtlCol="0" anchor="ctr"/>
+          <a:lstStyle/>
+          <a:p>
+            <a:pPr algn="r" indent="0" marL="0">
+              <a:buNone/>
+            </a:pPr>
+            <a:r>
+              <a:rPr lang="en-US" sz="800" dirty="0">
+                <a:solidFill>
+                  <a:srgbClr val="8B8FA3"/>
+                </a:solidFill>
+              </a:rPr>
+              <a:t>datacendia.com</a:t>
+            </a:r>
+            <a:endParaRPr lang="en-US" sz="800" dirty="0"/>
+          </a:p>
+        </p:txBody>
+      </p:sp>
       <p:pic>
         <p:nvPicPr>
-          <p:cNvPr id="7" name="Image 0" descr="preencoded.png">    </p:cNvPr>
+          <p:cNvPr id="10" name="Picture 9" descr="image.png"/>
           <p:cNvPicPr>
             <a:picLocks noChangeAspect="1"/>
           </p:cNvPicPr>
@@ -4815,78 +4887,6 @@
           </a:prstGeom>
         </p:spPr>
       </p:pic>
-      <p:sp>
-        <p:nvSpPr>
-          <p:cNvPr id="8" name="Text 5"/>
-          <p:cNvSpPr/>
-          <p:nvPr/>
-        </p:nvSpPr>
-        <p:spPr>
-          <a:xfrm>
-            <a:off x="457200" y="6400800"/>
-            <a:ext cx="3657600" cy="274320"/>
-          </a:xfrm>
-          <a:prstGeom prst="rect">
-            <a:avLst/>
-          </a:prstGeom>
-          <a:noFill/>
-          <a:ln/>
-        </p:spPr>
-        <p:txBody>
-          <a:bodyPr wrap="square" rtlCol="0" anchor="ctr"/>
-          <a:lstStyle/>
-          <a:p>
-            <a:pPr indent="0" marL="0">
-              <a:buNone/>
-            </a:pPr>
-            <a:r>
-              <a:rPr lang="en-US" sz="800" dirty="0">
-                <a:solidFill>
-                  <a:srgbClr val="8B8FA3"/>
-                </a:solidFill>
-              </a:rPr>
-              <a:t>© 2024-2026 Datacendia, LLC</a:t>
-            </a:r>
-            <a:endParaRPr lang="en-US" sz="800" dirty="0"/>
-          </a:p>
-        </p:txBody>
-      </p:sp>
-      <p:sp>
-        <p:nvSpPr>
-          <p:cNvPr id="9" name="Text 6"/>
-          <p:cNvSpPr/>
-          <p:nvPr/>
-        </p:nvSpPr>
-        <p:spPr>
-          <a:xfrm>
-            <a:off x="8229600" y="6400800"/>
-            <a:ext cx="3657600" cy="274320"/>
-          </a:xfrm>
-          <a:prstGeom prst="rect">
-            <a:avLst/>
-          </a:prstGeom>
-          <a:noFill/>
-          <a:ln/>
-        </p:spPr>
-        <p:txBody>
-          <a:bodyPr wrap="square" rtlCol="0" anchor="ctr"/>
-          <a:lstStyle/>
-          <a:p>
-            <a:pPr algn="r" indent="0" marL="0">
-              <a:buNone/>
-            </a:pPr>
-            <a:r>
-              <a:rPr lang="en-US" sz="800" dirty="0">
-                <a:solidFill>
-                  <a:srgbClr val="8B8FA3"/>
-                </a:solidFill>
-              </a:rPr>
-              <a:t>datacendia.com</a:t>
-            </a:r>
-            <a:endParaRPr lang="en-US" sz="800" dirty="0"/>
-          </a:p>
-        </p:txBody>
-      </p:sp>
     </p:spTree>
   </p:cSld>
   <p:clrMapOvr>

</xml_diff>